<commit_message>
Pôster mais enxuto, com o teste do app em sono real
</commit_message>
<xml_diff>
--- a/poster/poster_final.pptx
+++ b/poster/poster_final.pptx
@@ -11493,7 +11493,7 @@
           <a:p>
             <a:pPr algn="l">
               <a:lnSpc>
-                <a:spcPts val="2180"/>
+                <a:spcPts val="2200"/>
               </a:lnSpc>
               <a:buNone/>
             </a:pPr>
@@ -11507,7 +11507,7 @@
                 <a:cs typeface="Arial"/>
                 <a:sym typeface="Arial"/>
               </a:rPr>
-              <a:t>A saúde do condutor, sono</a:t>
+              <a:t>Sono e saúde do condutor pesam</a:t>
             </a:r>
             <a:br>
               <a:rPr lang="pt-BR" sz="2000"/>
@@ -11522,7 +11522,7 @@
                 <a:cs typeface="Arial"/>
                 <a:sym typeface="Arial"/>
               </a:rPr>
-              <a:t>incluído, aparece em </a:t>
+              <a:t>em </a:t>
             </a:r>
             <a:r>
               <a:rPr sz="2000" b="1" lang="pt-BR">
@@ -11546,7 +11546,7 @@
                 <a:cs typeface="Arial"/>
                 <a:sym typeface="Arial"/>
               </a:rPr>
-              <a:t> das</a:t>
+              <a:t> das ocorrências nas</a:t>
             </a:r>
             <a:br>
               <a:rPr lang="pt-BR" sz="2000"/>
@@ -11561,31 +11561,16 @@
                 <a:cs typeface="Arial"/>
                 <a:sym typeface="Arial"/>
               </a:rPr>
-              <a:t>ocorrências nas rodovias federais</a:t>
-            </a:r>
-            <a:br>
-              <a:rPr lang="pt-BR" sz="2000"/>
-            </a:br>
-            <a:r>
-              <a:rPr sz="2000" b="0" lang="pt-BR">
-                <a:solidFill>
-                  <a:srgbClr val="1A1A1A"/>
-                </a:solidFill>
-                <a:latin typeface="Arial"/>
-                <a:ea typeface="Arial"/>
-                <a:cs typeface="Arial"/>
-                <a:sym typeface="Arial"/>
-              </a:rPr>
-              <a:t>[7].</a:t>
+              <a:t>rodovias federais [7].</a:t>
             </a:r>
           </a:p>
           <a:p>
             <a:pPr algn="l">
               <a:lnSpc>
-                <a:spcPts val="2180"/>
+                <a:spcPts val="2200"/>
               </a:lnSpc>
               <a:spcBef>
-                <a:spcPts val="720"/>
+                <a:spcPts val="1400"/>
               </a:spcBef>
               <a:buNone/>
             </a:pPr>
@@ -11680,63 +11665,10 @@
           <a:p>
             <a:pPr algn="l">
               <a:lnSpc>
-                <a:spcPts val="2180"/>
+                <a:spcPts val="2200"/>
               </a:lnSpc>
               <a:spcBef>
-                <a:spcPts val="720"/>
-              </a:spcBef>
-              <a:buNone/>
-            </a:pPr>
-            <a:r>
-              <a:rPr sz="2000" b="0" lang="pt-BR">
-                <a:solidFill>
-                  <a:srgbClr val="1A1A1A"/>
-                </a:solidFill>
-                <a:latin typeface="Arial"/>
-                <a:ea typeface="Arial"/>
-                <a:cs typeface="Arial"/>
-                <a:sym typeface="Arial"/>
-              </a:rPr>
-              <a:t>Outro cuidado: dividir treino e teste</a:t>
-            </a:r>
-            <a:br>
-              <a:rPr lang="pt-BR" sz="2000"/>
-            </a:br>
-            <a:r>
-              <a:rPr sz="2000" b="0" lang="pt-BR">
-                <a:solidFill>
-                  <a:srgbClr val="1A1A1A"/>
-                </a:solidFill>
-                <a:latin typeface="Arial"/>
-                <a:ea typeface="Arial"/>
-                <a:cs typeface="Arial"/>
-                <a:sym typeface="Arial"/>
-              </a:rPr>
-              <a:t>por janela põe trechos do mesmo</a:t>
-            </a:r>
-            <a:br>
-              <a:rPr lang="pt-BR" sz="2000"/>
-            </a:br>
-            <a:r>
-              <a:rPr sz="2000" b="0" lang="pt-BR">
-                <a:solidFill>
-                  <a:srgbClr val="1A1A1A"/>
-                </a:solidFill>
-                <a:latin typeface="Arial"/>
-                <a:ea typeface="Arial"/>
-                <a:cs typeface="Arial"/>
-                <a:sym typeface="Arial"/>
-              </a:rPr>
-              <a:t>vídeo nos dois lados (vazamento).</a:t>
-            </a:r>
-          </a:p>
-          <a:p>
-            <a:pPr algn="l">
-              <a:lnSpc>
-                <a:spcPts val="2180"/>
-              </a:lnSpc>
-              <a:spcBef>
-                <a:spcPts val="1260"/>
+                <a:spcPts val="3000"/>
               </a:spcBef>
               <a:buNone/>
             </a:pPr>
@@ -11756,10 +11688,10 @@
           <a:p>
             <a:pPr algn="l">
               <a:lnSpc>
-                <a:spcPts val="2180"/>
+                <a:spcPts val="2200"/>
               </a:lnSpc>
               <a:spcBef>
-                <a:spcPts val="180"/>
+                <a:spcPts val="400"/>
               </a:spcBef>
               <a:buNone/>
             </a:pPr>
@@ -11809,10 +11741,10 @@
           <a:p>
             <a:pPr algn="l">
               <a:lnSpc>
-                <a:spcPts val="2180"/>
+                <a:spcPts val="2200"/>
               </a:lnSpc>
               <a:spcBef>
-                <a:spcPts val="1260"/>
+                <a:spcPts val="3000"/>
               </a:spcBef>
               <a:buNone/>
             </a:pPr>
@@ -11832,10 +11764,10 @@
           <a:p>
             <a:pPr algn="l">
               <a:lnSpc>
-                <a:spcPts val="2180"/>
+                <a:spcPts val="2200"/>
               </a:lnSpc>
               <a:spcBef>
-                <a:spcPts val="180"/>
+                <a:spcPts val="400"/>
               </a:spcBef>
               <a:buNone/>
             </a:pPr>
@@ -11882,10 +11814,10 @@
           <a:p>
             <a:pPr algn="l">
               <a:lnSpc>
-                <a:spcPts val="2180"/>
+                <a:spcPts val="2200"/>
               </a:lnSpc>
               <a:spcBef>
-                <a:spcPts val="450"/>
+                <a:spcPts val="1000"/>
               </a:spcBef>
               <a:buNone/>
             </a:pPr>
@@ -11917,10 +11849,10 @@
           <a:p>
             <a:pPr algn="l">
               <a:lnSpc>
-                <a:spcPts val="2180"/>
+                <a:spcPts val="2200"/>
               </a:lnSpc>
               <a:spcBef>
-                <a:spcPts val="450"/>
+                <a:spcPts val="1000"/>
               </a:spcBef>
               <a:buNone/>
             </a:pPr>
@@ -12157,7 +12089,7 @@
                 <a:cs typeface="Arial"/>
                 <a:sym typeface="Arial"/>
               </a:rPr>
-              <a:t>teste real (PP1)</a:t>
+              <a:t>teste (PP1)</a:t>
             </a:r>
           </a:p>
         </p:txBody>
@@ -12286,7 +12218,7 @@
                 <a:cs typeface="Arial"/>
                 <a:sym typeface="Arial"/>
               </a:rPr>
-              <a:t>treino atuado (PP1)</a:t>
+              <a:t>treino (PP1)</a:t>
             </a:r>
           </a:p>
         </p:txBody>
@@ -12699,16 +12631,40 @@
           </a:p>
         </p:txBody>
       </p:sp>
+      <p:pic>
+        <p:nvPicPr>
+          <p:cNvPr id="148" name="fig_poster_exp5b.png" descr="fig_poster_exp5b.png"/>
+          <p:cNvPicPr>
+            <a:picLocks noChangeAspect="1"/>
+          </p:cNvPicPr>
+          <p:nvPr/>
+        </p:nvPicPr>
+        <p:blipFill>
+          <a:blip r:embed="rId8"/>
+          <a:stretch>
+            <a:fillRect/>
+          </a:stretch>
+        </p:blipFill>
+        <p:spPr>
+          <a:xfrm>
+            <a:off x="5130000" y="6562800"/>
+            <a:ext cx="3960000" cy="3435479"/>
+          </a:xfrm>
+          <a:prstGeom prst="rect">
+            <a:avLst/>
+          </a:prstGeom>
+        </p:spPr>
+      </p:pic>
       <p:sp>
         <p:nvSpPr>
-          <p:cNvPr id="148" name="Legenda Exp 5b"/>
+          <p:cNvPr id="149" name="Vazamento"/>
           <p:cNvSpPr txBox="1"/>
           <p:nvPr/>
         </p:nvSpPr>
         <p:spPr>
           <a:xfrm>
-            <a:off x="5130000" y="6562800"/>
-            <a:ext cx="3960000" cy="856080"/>
+            <a:off x="9270000" y="6562800"/>
+            <a:ext cx="3906000" cy="1694520"/>
           </a:xfrm>
           <a:prstGeom prst="rect">
             <a:avLst/>
@@ -12737,8 +12693,16 @@
                 <a:cs typeface="Arial"/>
                 <a:sym typeface="Arial"/>
               </a:rPr>
-              <a:t>PP1:</a:t>
+              <a:t>Vazamento</a:t>
             </a:r>
+          </a:p>
+          <a:p>
+            <a:pPr algn="l">
+              <a:lnSpc>
+                <a:spcPts val="2200"/>
+              </a:lnSpc>
+              <a:buNone/>
+            </a:pPr>
             <a:r>
               <a:rPr sz="2000" b="0" lang="pt-BR">
                 <a:solidFill>
@@ -12749,7 +12713,7 @@
                 <a:cs typeface="Arial"/>
                 <a:sym typeface="Arial"/>
               </a:rPr>
-              <a:t> C = DMD → UTA,</a:t>
+              <a:t>Nas sequências de piscadas,</a:t>
             </a:r>
             <a:br>
               <a:rPr lang="pt-BR" sz="2000"/>
@@ -12764,7 +12728,7 @@
                 <a:cs typeface="Arial"/>
                 <a:sym typeface="Arial"/>
               </a:rPr>
-              <a:t>B = UTA → UTA. Outras: outra</a:t>
+              <a:t>que se sobrepõem, partir por</a:t>
             </a:r>
             <a:br>
               <a:rPr lang="pt-BR" sz="2000"/>
@@ -12779,45 +12743,51 @@
                 <a:cs typeface="Arial"/>
                 <a:sym typeface="Arial"/>
               </a:rPr>
-              <a:t>referência ou sem centragem.</a:t>
+              <a:t>janela infla a acurácia em</a:t>
+            </a:r>
+            <a:br>
+              <a:rPr lang="pt-BR" sz="2000"/>
+            </a:br>
+            <a:r>
+              <a:rPr sz="2000" b="0" lang="pt-BR">
+                <a:solidFill>
+                  <a:srgbClr val="1A1A1A"/>
+                </a:solidFill>
+                <a:latin typeface="Arial"/>
+                <a:ea typeface="Arial"/>
+                <a:cs typeface="Arial"/>
+                <a:sym typeface="Arial"/>
+              </a:rPr>
+              <a:t>45,3 pp; nas janelas de 10 s,</a:t>
+            </a:r>
+            <a:br>
+              <a:rPr lang="pt-BR" sz="2000"/>
+            </a:br>
+            <a:r>
+              <a:rPr sz="2000" b="0" lang="pt-BR">
+                <a:solidFill>
+                  <a:srgbClr val="1A1A1A"/>
+                </a:solidFill>
+                <a:latin typeface="Arial"/>
+                <a:ea typeface="Arial"/>
+                <a:cs typeface="Arial"/>
+                <a:sym typeface="Arial"/>
+              </a:rPr>
+              <a:t>12,6 pp no RF e 1,2 pp na RL.</a:t>
             </a:r>
           </a:p>
         </p:txBody>
       </p:sp>
-      <p:pic>
-        <p:nvPicPr>
-          <p:cNvPr id="149" name="fig_poster_exp5b.png" descr="fig_poster_exp5b.png"/>
-          <p:cNvPicPr>
-            <a:picLocks noChangeAspect="1"/>
-          </p:cNvPicPr>
-          <p:nvPr/>
-        </p:nvPicPr>
-        <p:blipFill>
-          <a:blip r:embed="rId8"/>
-          <a:stretch>
-            <a:fillRect/>
-          </a:stretch>
-        </p:blipFill>
-        <p:spPr>
-          <a:xfrm>
-            <a:off x="5130000" y="7444800"/>
-            <a:ext cx="3960000" cy="2554560"/>
-          </a:xfrm>
-          <a:prstGeom prst="rect">
-            <a:avLst/>
-          </a:prstGeom>
-        </p:spPr>
-      </p:pic>
       <p:sp>
         <p:nvSpPr>
-          <p:cNvPr id="150" name="Vazamento"/>
+          <p:cNvPr id="150" name="App"/>
           <p:cNvSpPr txBox="1"/>
           <p:nvPr/>
         </p:nvSpPr>
         <p:spPr>
           <a:xfrm>
-            <a:off x="9270000" y="6562800"/>
-            <a:ext cx="3906000" cy="1719720"/>
+            <a:off x="9270000" y="8311200"/>
+            <a:ext cx="3906000" cy="1689599"/>
           </a:xfrm>
           <a:prstGeom prst="rect">
             <a:avLst/>
@@ -12846,132 +12816,6 @@
                 <a:cs typeface="Arial"/>
                 <a:sym typeface="Arial"/>
               </a:rPr>
-              <a:t>Vazamento</a:t>
-            </a:r>
-          </a:p>
-          <a:p>
-            <a:pPr algn="l">
-              <a:lnSpc>
-                <a:spcPts val="2200"/>
-              </a:lnSpc>
-              <a:spcBef>
-                <a:spcPts val="200"/>
-              </a:spcBef>
-              <a:buNone/>
-            </a:pPr>
-            <a:r>
-              <a:rPr sz="2000" b="0" lang="pt-BR">
-                <a:solidFill>
-                  <a:srgbClr val="1A1A1A"/>
-                </a:solidFill>
-                <a:latin typeface="Arial"/>
-                <a:ea typeface="Arial"/>
-                <a:cs typeface="Arial"/>
-                <a:sym typeface="Arial"/>
-              </a:rPr>
-              <a:t>Nas sequências de piscadas,</a:t>
-            </a:r>
-            <a:br>
-              <a:rPr lang="pt-BR" sz="2000"/>
-            </a:br>
-            <a:r>
-              <a:rPr sz="2000" b="0" lang="pt-BR">
-                <a:solidFill>
-                  <a:srgbClr val="1A1A1A"/>
-                </a:solidFill>
-                <a:latin typeface="Arial"/>
-                <a:ea typeface="Arial"/>
-                <a:cs typeface="Arial"/>
-                <a:sym typeface="Arial"/>
-              </a:rPr>
-              <a:t>que se sobrepõem, partir por</a:t>
-            </a:r>
-            <a:br>
-              <a:rPr lang="pt-BR" sz="2000"/>
-            </a:br>
-            <a:r>
-              <a:rPr sz="2000" b="0" lang="pt-BR">
-                <a:solidFill>
-                  <a:srgbClr val="1A1A1A"/>
-                </a:solidFill>
-                <a:latin typeface="Arial"/>
-                <a:ea typeface="Arial"/>
-                <a:cs typeface="Arial"/>
-                <a:sym typeface="Arial"/>
-              </a:rPr>
-              <a:t>janela infla a acurácia em</a:t>
-            </a:r>
-            <a:br>
-              <a:rPr lang="pt-BR" sz="2000"/>
-            </a:br>
-            <a:r>
-              <a:rPr sz="2000" b="0" lang="pt-BR">
-                <a:solidFill>
-                  <a:srgbClr val="1A1A1A"/>
-                </a:solidFill>
-                <a:latin typeface="Arial"/>
-                <a:ea typeface="Arial"/>
-                <a:cs typeface="Arial"/>
-                <a:sym typeface="Arial"/>
-              </a:rPr>
-              <a:t>45,3 pp; nas janelas de 10 s,</a:t>
-            </a:r>
-            <a:br>
-              <a:rPr lang="pt-BR" sz="2000"/>
-            </a:br>
-            <a:r>
-              <a:rPr sz="2000" b="0" lang="pt-BR">
-                <a:solidFill>
-                  <a:srgbClr val="1A1A1A"/>
-                </a:solidFill>
-                <a:latin typeface="Arial"/>
-                <a:ea typeface="Arial"/>
-                <a:cs typeface="Arial"/>
-                <a:sym typeface="Arial"/>
-              </a:rPr>
-              <a:t>12,6 pp no RF e 1,2 pp na RL.</a:t>
-            </a:r>
-          </a:p>
-        </p:txBody>
-      </p:sp>
-      <p:sp>
-        <p:nvSpPr>
-          <p:cNvPr id="151" name="App"/>
-          <p:cNvSpPr txBox="1"/>
-          <p:nvPr/>
-        </p:nvSpPr>
-        <p:spPr>
-          <a:xfrm>
-            <a:off x="9270000" y="8426600"/>
-            <a:ext cx="3906000" cy="1574199"/>
-          </a:xfrm>
-          <a:prstGeom prst="rect">
-            <a:avLst/>
-          </a:prstGeom>
-          <a:noFill/>
-        </p:spPr>
-        <p:txBody>
-          <a:bodyPr wrap="square" lIns="0" rIns="0" tIns="0" bIns="0" anchor="t">
-            <a:noAutofit/>
-          </a:bodyPr>
-          <a:lstStyle/>
-          <a:p>
-            <a:pPr algn="l">
-              <a:lnSpc>
-                <a:spcPts val="2200"/>
-              </a:lnSpc>
-              <a:buNone/>
-            </a:pPr>
-            <a:r>
-              <a:rPr sz="2000" b="1" lang="pt-BR">
-                <a:solidFill>
-                  <a:srgbClr val="1A1A1A"/>
-                </a:solidFill>
-                <a:latin typeface="Arial"/>
-                <a:ea typeface="Arial"/>
-                <a:cs typeface="Arial"/>
-                <a:sym typeface="Arial"/>
-              </a:rPr>
               <a:t>App v2.1</a:t>
             </a:r>
           </a:p>
@@ -12980,9 +12824,6 @@
               <a:lnSpc>
                 <a:spcPts val="2200"/>
               </a:lnSpc>
-              <a:spcBef>
-                <a:spcPts val="200"/>
-              </a:spcBef>
               <a:buNone/>
             </a:pPr>
             <a:r>
@@ -12995,7 +12836,7 @@
                 <a:cs typeface="Arial"/>
                 <a:sym typeface="Arial"/>
               </a:rPr>
-              <a:t>Regras sobre olhos, bocejo e</a:t>
+              <a:t>Em 24 pessoas com sono real,</a:t>
             </a:r>
             <a:br>
               <a:rPr lang="pt-BR" sz="2000"/>
@@ -13010,7 +12851,7 @@
                 <a:cs typeface="Arial"/>
                 <a:sym typeface="Arial"/>
               </a:rPr>
-              <a:t>cabeça. Na direção real do DMD</a:t>
+              <a:t>fora do ajuste, separou</a:t>
             </a:r>
             <a:br>
               <a:rPr lang="pt-BR" sz="2000"/>
@@ -13025,7 +12866,7 @@
                 <a:cs typeface="Arial"/>
                 <a:sym typeface="Arial"/>
               </a:rPr>
-              <a:t>(63 min, usados no ajuste), ficou</a:t>
+              <a:t>sonolento de acordado</a:t>
             </a:r>
             <a:br>
               <a:rPr lang="pt-BR" sz="2000"/>
@@ -13040,14 +12881,29 @@
                 <a:cs typeface="Arial"/>
                 <a:sym typeface="Arial"/>
               </a:rPr>
-              <a:t>3,3% do tempo em vermelho.</a:t>
+              <a:t>(AUC 0,812); alarmou 15</a:t>
+            </a:r>
+            <a:br>
+              <a:rPr lang="pt-BR" sz="2000"/>
+            </a:br>
+            <a:r>
+              <a:rPr sz="2000" b="0" lang="pt-BR">
+                <a:solidFill>
+                  <a:srgbClr val="1A1A1A"/>
+                </a:solidFill>
+                <a:latin typeface="Arial"/>
+                <a:ea typeface="Arial"/>
+                <a:cs typeface="Arial"/>
+                <a:sym typeface="Arial"/>
+              </a:rPr>
+              <a:t>sonolentos e 2 acordados.</a:t>
             </a:r>
           </a:p>
         </p:txBody>
       </p:sp>
       <p:sp>
         <p:nvSpPr>
-          <p:cNvPr id="152" name="Titulo col 3"/>
+          <p:cNvPr id="151" name="Titulo col 3"/>
           <p:cNvSpPr txBox="1"/>
           <p:nvPr/>
         </p:nvSpPr>
@@ -13090,7 +12946,7 @@
       </p:sp>
       <p:sp>
         <p:nvSpPr>
-          <p:cNvPr id="153" name="Sintese"/>
+          <p:cNvPr id="152" name="Sintese"/>
           <p:cNvSpPr txBox="1"/>
           <p:nvPr/>
         </p:nvSpPr>
@@ -13178,14 +13034,14 @@
       </p:sp>
       <p:sp>
         <p:nvSpPr>
-          <p:cNvPr id="154" name="Corpo col 3"/>
+          <p:cNvPr id="153" name="Corpo col 3"/>
           <p:cNvSpPr txBox="1"/>
           <p:nvPr/>
         </p:nvSpPr>
         <p:spPr>
           <a:xfrm>
-            <a:off x="13680000" y="4419120"/>
-            <a:ext cx="4194000" cy="4267619"/>
+            <a:off x="13680000" y="4527120"/>
+            <a:ext cx="4194000" cy="4159619"/>
           </a:xfrm>
           <a:prstGeom prst="rect">
             <a:avLst/>
@@ -13200,7 +13056,7 @@
           <a:p>
             <a:pPr algn="l">
               <a:lnSpc>
-                <a:spcPts val="2140"/>
+                <a:spcPts val="2200"/>
               </a:lnSpc>
               <a:buNone/>
             </a:pPr>
@@ -13226,7 +13082,7 @@
                 <a:cs typeface="Arial"/>
                 <a:sym typeface="Arial"/>
               </a:rPr>
-              <a:t> Treinada no DMD, a RL</a:t>
+              <a:t> A RL do DMD perde de 5,4 a</a:t>
             </a:r>
             <a:br>
               <a:rPr lang="pt-BR" sz="2000"/>
@@ -13241,7 +13097,7 @@
                 <a:cs typeface="Arial"/>
                 <a:sym typeface="Arial"/>
               </a:rPr>
-              <a:t>perde de 5,4 a 9,8 pontos de AUC</a:t>
+              <a:t>9,8 pontos de AUC em todas as</a:t>
             </a:r>
             <a:br>
               <a:rPr lang="pt-BR" sz="2000"/>
@@ -13256,7 +13112,7 @@
                 <a:cs typeface="Arial"/>
                 <a:sym typeface="Arial"/>
               </a:rPr>
-              <a:t>em todas as normalizações</a:t>
+              <a:t>normalizações testadas; o RF</a:t>
             </a:r>
             <a:br>
               <a:rPr lang="pt-BR" sz="2000"/>
@@ -13271,7 +13127,7 @@
                 <a:cs typeface="Arial"/>
                 <a:sym typeface="Arial"/>
               </a:rPr>
-              <a:t>testadas; o RF perde 10,9 só na</a:t>
+              <a:t>perde 10,9 só com a referência</a:t>
             </a:r>
             <a:br>
               <a:rPr lang="pt-BR" sz="2000"/>
@@ -13286,16 +13142,16 @@
                 <a:cs typeface="Arial"/>
                 <a:sym typeface="Arial"/>
               </a:rPr>
-              <a:t>principal.</a:t>
+              <a:t>principal na UTA.</a:t>
             </a:r>
           </a:p>
           <a:p>
             <a:pPr algn="l">
               <a:lnSpc>
-                <a:spcPts val="2140"/>
+                <a:spcPts val="2200"/>
               </a:lnSpc>
               <a:spcBef>
-                <a:spcPts val="420"/>
+                <a:spcPts val="1400"/>
               </a:spcBef>
               <a:buNone/>
             </a:pPr>
@@ -13342,10 +13198,10 @@
           <a:p>
             <a:pPr algn="l">
               <a:lnSpc>
-                <a:spcPts val="2140"/>
+                <a:spcPts val="2200"/>
               </a:lnSpc>
               <a:spcBef>
-                <a:spcPts val="420"/>
+                <a:spcPts val="1400"/>
               </a:spcBef>
               <a:buNone/>
             </a:pPr>
@@ -13371,7 +13227,7 @@
                 <a:cs typeface="Arial"/>
                 <a:sym typeface="Arial"/>
               </a:rPr>
-              <a:t> À noite, a SNR do EAR</a:t>
+              <a:t> A SNR do EAR (abertura do</a:t>
             </a:r>
             <a:br>
               <a:rPr lang="pt-BR" sz="2000"/>
@@ -13386,7 +13242,7 @@
                 <a:cs typeface="Arial"/>
                 <a:sym typeface="Arial"/>
               </a:rPr>
-              <a:t>(abertura do olho) cai para 7,2,</a:t>
+              <a:t>olho) é 7,2 à noite e 8,7 com o</a:t>
             </a:r>
             <a:br>
               <a:rPr lang="pt-BR" sz="2000"/>
@@ -13401,7 +13257,7 @@
                 <a:cs typeface="Arial"/>
                 <a:sym typeface="Arial"/>
               </a:rPr>
-              <a:t>mas o carro andando de dia já dá</a:t>
+              <a:t>carro andando de dia. Óculos:</a:t>
             </a:r>
             <a:br>
               <a:rPr lang="pt-BR" sz="2000"/>
@@ -13416,31 +13272,16 @@
                 <a:cs typeface="Arial"/>
                 <a:sym typeface="Arial"/>
               </a:rPr>
-              <a:t>8,7. Óculos: AUC do olho de 93,4</a:t>
-            </a:r>
-            <a:br>
-              <a:rPr lang="pt-BR" sz="2000"/>
-            </a:br>
-            <a:r>
-              <a:rPr sz="2000" b="0" lang="pt-BR">
-                <a:solidFill>
-                  <a:srgbClr val="1A1A1A"/>
-                </a:solidFill>
-                <a:latin typeface="Arial"/>
-                <a:ea typeface="Arial"/>
-                <a:cs typeface="Arial"/>
-                <a:sym typeface="Arial"/>
-              </a:rPr>
-              <a:t>para 65,1 (CEW para MRL).</a:t>
+              <a:t>AUC do olho de 93,4 para 65,1.</a:t>
             </a:r>
           </a:p>
           <a:p>
             <a:pPr algn="l">
               <a:lnSpc>
-                <a:spcPts val="2140"/>
+                <a:spcPts val="2200"/>
               </a:lnSpc>
               <a:spcBef>
-                <a:spcPts val="420"/>
+                <a:spcPts val="1400"/>
               </a:spcBef>
               <a:buNone/>
             </a:pPr>
@@ -13466,44 +13307,14 @@
                 <a:cs typeface="Arial"/>
                 <a:sym typeface="Arial"/>
               </a:rPr>
-              <a:t> Um par de bases, 13</a:t>
-            </a:r>
-            <a:br>
-              <a:rPr lang="pt-BR" sz="2000"/>
-            </a:br>
-            <a:r>
-              <a:rPr sz="2000" b="0" lang="pt-BR">
-                <a:solidFill>
-                  <a:srgbClr val="1A1A1A"/>
-                </a:solidFill>
-                <a:latin typeface="Arial"/>
-                <a:ea typeface="Arial"/>
-                <a:cs typeface="Arial"/>
-                <a:sym typeface="Arial"/>
-              </a:rPr>
-              <a:t>pessoas no DMD e noite sem</a:t>
-            </a:r>
-            <a:br>
-              <a:rPr lang="pt-BR" sz="2000"/>
-            </a:br>
-            <a:r>
-              <a:rPr sz="2000" b="0" lang="pt-BR">
-                <a:solidFill>
-                  <a:srgbClr val="1A1A1A"/>
-                </a:solidFill>
-                <a:latin typeface="Arial"/>
-                <a:ea typeface="Arial"/>
-                <a:cs typeface="Arial"/>
-                <a:sym typeface="Arial"/>
-              </a:rPr>
-              <a:t>classe alerta.</a:t>
+              <a:t> Um só par de bases.</a:t>
             </a:r>
           </a:p>
         </p:txBody>
       </p:sp>
       <p:sp>
         <p:nvSpPr>
-          <p:cNvPr id="155" name="Referencias"/>
+          <p:cNvPr id="154" name="Referencias"/>
           <p:cNvSpPr txBox="1"/>
           <p:nvPr/>
         </p:nvSpPr>

</xml_diff>

<commit_message>
Pôster: correções da segunda revisão (revocação, frase-síntese, fontes e referência do NITYMED)
</commit_message>
<xml_diff>
--- a/poster/poster_final.pptx
+++ b/poster/poster_final.pptx
@@ -11148,7 +11148,7 @@
         </p:nvSpPr>
         <p:spPr>
           <a:xfrm>
-            <a:off x="4978800" y="344360"/>
+            <a:off x="4978800" y="316420"/>
             <a:ext cx="8348400" cy="1298160"/>
           </a:xfrm>
           <a:prstGeom prst="rect">
@@ -11221,8 +11221,8 @@
         </p:nvSpPr>
         <p:spPr>
           <a:xfrm>
-            <a:off x="4978800" y="1732520"/>
-            <a:ext cx="8348400" cy="241560"/>
+            <a:off x="4978800" y="1704580"/>
+            <a:ext cx="8348400" cy="297360"/>
           </a:xfrm>
           <a:prstGeom prst="rect">
             <a:avLst/>
@@ -11237,12 +11237,12 @@
           <a:p>
             <a:pPr algn="ctr">
               <a:lnSpc>
-                <a:spcPts val="1760"/>
+                <a:spcPts val="2200"/>
               </a:lnSpc>
               <a:buNone/>
             </a:pPr>
             <a:r>
-              <a:rPr sz="1600" b="0" lang="pt-BR">
+              <a:rPr sz="2000" b="0" lang="pt-BR">
                 <a:solidFill>
                   <a:srgbClr val="595959"/>
                 </a:solidFill>
@@ -11507,7 +11507,7 @@
                 <a:cs typeface="Arial"/>
                 <a:sym typeface="Arial"/>
               </a:rPr>
-              <a:t>Sono e saúde do condutor pesam</a:t>
+              <a:t>Condições de saúde do condutor,</a:t>
             </a:r>
             <a:br>
               <a:rPr lang="pt-BR" sz="2000"/>
@@ -11522,7 +11522,7 @@
                 <a:cs typeface="Arial"/>
                 <a:sym typeface="Arial"/>
               </a:rPr>
-              <a:t>em </a:t>
+              <a:t>sono incluído, pesam em </a:t>
             </a:r>
             <a:r>
               <a:rPr sz="2000" b="1" lang="pt-BR">
@@ -11536,6 +11536,9 @@
               </a:rPr>
               <a:t>27,8%</a:t>
             </a:r>
+            <a:br>
+              <a:rPr lang="pt-BR" sz="2000"/>
+            </a:br>
             <a:r>
               <a:rPr sz="2000" b="0" lang="pt-BR">
                 <a:solidFill>
@@ -11546,7 +11549,7 @@
                 <a:cs typeface="Arial"/>
                 <a:sym typeface="Arial"/>
               </a:rPr>
-              <a:t> das ocorrências nas</a:t>
+              <a:t>das ocorrências nas rodovias</a:t>
             </a:r>
             <a:br>
               <a:rPr lang="pt-BR" sz="2000"/>
@@ -11561,7 +11564,7 @@
                 <a:cs typeface="Arial"/>
                 <a:sym typeface="Arial"/>
               </a:rPr>
-              <a:t>rodovias federais [7].</a:t>
+              <a:t>federais [7].</a:t>
             </a:r>
           </a:p>
           <a:p>
@@ -11629,7 +11632,7 @@
                 <a:cs typeface="Arial"/>
                 <a:sym typeface="Arial"/>
               </a:rPr>
-              <a:t>(UTA-RLDD), o melhor modelo</a:t>
+              <a:t>(UTA-RLDD), o modelo dos</a:t>
             </a:r>
             <a:br>
               <a:rPr lang="pt-BR" sz="2000"/>
@@ -11644,7 +11647,7 @@
                 <a:cs typeface="Arial"/>
                 <a:sym typeface="Arial"/>
               </a:rPr>
-              <a:t>acerta 65,2% dos vídeos, e</a:t>
+              <a:t>autores da base acerta 65,2% dos</a:t>
             </a:r>
             <a:br>
               <a:rPr lang="pt-BR" sz="2000"/>
@@ -11659,7 +11662,7 @@
                 <a:cs typeface="Arial"/>
                 <a:sym typeface="Arial"/>
               </a:rPr>
-              <a:t>pessoas, 57,8% [1].</a:t>
+              <a:t>vídeos, e pessoas, 57,8% [1].</a:t>
             </a:r>
           </a:p>
           <a:p>
@@ -12851,7 +12854,7 @@
                 <a:cs typeface="Arial"/>
                 <a:sym typeface="Arial"/>
               </a:rPr>
-              <a:t>fora do ajuste, separou</a:t>
+              <a:t>sentadas e fora do ajuste,</a:t>
             </a:r>
             <a:br>
               <a:rPr lang="pt-BR" sz="2000"/>
@@ -12866,7 +12869,7 @@
                 <a:cs typeface="Arial"/>
                 <a:sym typeface="Arial"/>
               </a:rPr>
-              <a:t>sonolento de acordado</a:t>
+              <a:t>separou sonolento de acordado</a:t>
             </a:r>
             <a:br>
               <a:rPr lang="pt-BR" sz="2000"/>
@@ -12953,7 +12956,7 @@
         <p:spPr>
           <a:xfrm>
             <a:off x="13680000" y="2970000"/>
-            <a:ext cx="4194000" cy="1359000"/>
+            <a:ext cx="4194000" cy="1694520"/>
           </a:xfrm>
           <a:prstGeom prst="rect">
             <a:avLst/>
@@ -12982,7 +12985,7 @@
                 <a:cs typeface="Arial"/>
                 <a:sym typeface="Arial"/>
               </a:rPr>
-              <a:t>Sono encenado é mais</a:t>
+              <a:t>Treinado com sono</a:t>
             </a:r>
             <a:br>
               <a:rPr lang="pt-BR" sz="2400"/>
@@ -12997,7 +13000,7 @@
                 <a:cs typeface="Arial"/>
                 <a:sym typeface="Arial"/>
               </a:rPr>
-              <a:t>extremo que o real: o modelo</a:t>
+              <a:t>encenado, o modelo só</a:t>
             </a:r>
             <a:br>
               <a:rPr lang="pt-BR" sz="2400"/>
@@ -13012,7 +13015,7 @@
                 <a:cs typeface="Arial"/>
                 <a:sym typeface="Arial"/>
               </a:rPr>
-              <a:t>do DMD reconhece só 48%</a:t>
+              <a:t>reconhece 48,4% das</a:t>
             </a:r>
             <a:br>
               <a:rPr lang="pt-BR" sz="2400"/>
@@ -13027,7 +13030,22 @@
                 <a:cs typeface="Arial"/>
                 <a:sym typeface="Arial"/>
               </a:rPr>
-              <a:t>das janelas de sono real.</a:t>
+              <a:t>janelas de sono real, com</a:t>
+            </a:r>
+            <a:br>
+              <a:rPr lang="pt-BR" sz="2400"/>
+            </a:br>
+            <a:r>
+              <a:rPr sz="2400" b="0" lang="pt-BR">
+                <a:solidFill>
+                  <a:srgbClr val="1A1A1A"/>
+                </a:solidFill>
+                <a:latin typeface="Arial"/>
+                <a:ea typeface="Arial"/>
+                <a:cs typeface="Arial"/>
+                <a:sym typeface="Arial"/>
+              </a:rPr>
+              <a:t>fechamentos mais curtos.</a:t>
             </a:r>
           </a:p>
         </p:txBody>
@@ -13040,8 +13058,8 @@
         </p:nvSpPr>
         <p:spPr>
           <a:xfrm>
-            <a:off x="13680000" y="4527120"/>
-            <a:ext cx="4194000" cy="4159619"/>
+            <a:off x="13680000" y="4772400"/>
+            <a:ext cx="4194000" cy="3914339"/>
           </a:xfrm>
           <a:prstGeom prst="rect">
             <a:avLst/>
@@ -13151,7 +13169,7 @@
                 <a:spcPts val="2200"/>
               </a:lnSpc>
               <a:spcBef>
-                <a:spcPts val="1400"/>
+                <a:spcPts val="600"/>
               </a:spcBef>
               <a:buNone/>
             </a:pPr>
@@ -13201,7 +13219,7 @@
                 <a:spcPts val="2200"/>
               </a:lnSpc>
               <a:spcBef>
-                <a:spcPts val="1400"/>
+                <a:spcPts val="600"/>
               </a:spcBef>
               <a:buNone/>
             </a:pPr>
@@ -13242,7 +13260,7 @@
                 <a:cs typeface="Arial"/>
                 <a:sym typeface="Arial"/>
               </a:rPr>
-              <a:t>olho) é 7,2 à noite e 8,7 com o</a:t>
+              <a:t>olho) é 7,2 à noite, 8,7 com o carro</a:t>
             </a:r>
             <a:br>
               <a:rPr lang="pt-BR" sz="2000"/>
@@ -13257,7 +13275,7 @@
                 <a:cs typeface="Arial"/>
                 <a:sym typeface="Arial"/>
               </a:rPr>
-              <a:t>carro andando de dia. Óculos:</a:t>
+              <a:t>andando e 13,6 parado, de dia.</a:t>
             </a:r>
             <a:br>
               <a:rPr lang="pt-BR" sz="2000"/>
@@ -13272,7 +13290,22 @@
                 <a:cs typeface="Arial"/>
                 <a:sym typeface="Arial"/>
               </a:rPr>
-              <a:t>AUC do olho de 93,4 para 65,1.</a:t>
+              <a:t>Óculos: AUC do olho de</a:t>
+            </a:r>
+            <a:br>
+              <a:rPr lang="pt-BR" sz="2000"/>
+            </a:br>
+            <a:r>
+              <a:rPr sz="2000" b="0" lang="pt-BR">
+                <a:solidFill>
+                  <a:srgbClr val="1A1A1A"/>
+                </a:solidFill>
+                <a:latin typeface="Arial"/>
+                <a:ea typeface="Arial"/>
+                <a:cs typeface="Arial"/>
+                <a:sym typeface="Arial"/>
+              </a:rPr>
+              <a:t>93,4 para 65,1.</a:t>
             </a:r>
           </a:p>
           <a:p>
@@ -13281,7 +13314,7 @@
                 <a:spcPts val="2200"/>
               </a:lnSpc>
               <a:spcBef>
-                <a:spcPts val="1400"/>
+                <a:spcPts val="600"/>
               </a:spcBef>
               <a:buNone/>
             </a:pPr>
@@ -13380,7 +13413,7 @@
                 <a:cs typeface="Arial"/>
                 <a:sym typeface="Arial"/>
               </a:rPr>
-              <a:t>et al., IEEE DataPort 2022. [4] Fusek, ISVC</a:t>
+              <a:t>et al., DataPort 2022; DSD 2021. [4] Fusek,</a:t>
             </a:r>
             <a:br>
               <a:rPr lang="pt-BR" sz="1600"/>
@@ -13395,7 +13428,7 @@
                 <a:cs typeface="Arial"/>
                 <a:sym typeface="Arial"/>
               </a:rPr>
-              <a:t>2018. [5] Song et al., Pattern Recognit.</a:t>
+              <a:t>ISVC 2018. [5] Song et al., Pattern</a:t>
             </a:r>
             <a:br>
               <a:rPr lang="pt-BR" sz="1600"/>
@@ -13410,7 +13443,7 @@
                 <a:cs typeface="Arial"/>
                 <a:sym typeface="Arial"/>
               </a:rPr>
-              <a:t>2014. [6] Lyu et al., arXiv 2018.</a:t>
+              <a:t>Recognit. 2014. [6] Lyu et al., arXiv 2018.</a:t>
             </a:r>
             <a:br>
               <a:rPr lang="pt-BR" sz="1600"/>

</xml_diff>